<commit_message>
Update deck: contrast pass + references analogy
Co-Authored-By: Claude Fable 5 <noreply@anthropic.com>
</commit_message>
<xml_diff>
--- a/bni-2026/deck-8373f356/demystifying-seo.pptx
+++ b/bni-2026/deck-8373f356/demystifying-seo.pptx
@@ -1306,7 +1306,7 @@
           <a:p>
             <a:r>
               <a:rPr lang="en-US" dirty="0"/>
-              <a:t>Part two is everything that exists about you outside your book. Eric keeps coming back to the flyer: your listings around town, other people pointing at your book, and what readers say. One rule above all: every flyer must match. Inconsistent name, address, or phone quietly kills trust.</a:t>
+              <a:t>Part two is everything that exists about you outside your book. Think of it like references, or peer review. Your card in the catalog, the books that cite yours, and what readers write on the review cards. The librarian weighs all of it, and you cannot write any of it yourself. One rule above all: every reference must match. An inconsistent name, address, or phone quietly kills trust.</a:t>
             </a:r>
             <a:endParaRPr lang="en-US" dirty="0"/>
           </a:p>
@@ -1394,7 +1394,7 @@
           <a:p>
             <a:r>
               <a:rPr lang="en-US" dirty="0"/>
-              <a:t>Put the two parts together and the decision is not magic: a book worth reading, flyers that agree, readers who come back. And ads? Ads are the folding table out front. Useful, instant, clearly labeled, and gone when the money stops. The recommendation cannot be bought. That is why it is worth more.</a:t>
+              <a:t>Put the two parts together and the decision is not magic: a book worth reading, references that agree, readers who come back. And ads? Ads are the flyers handed out on the sidewalk. Useful, instant, clearly labeled, and gone when the money stops. The recommendation cannot be bought. That is why it is worth more.</a:t>
             </a:r>
             <a:endParaRPr lang="en-US" dirty="0"/>
           </a:p>
@@ -2058,7 +2058,7 @@
         <p:spPr>
           <a:xfrm>
             <a:off x="822960" y="1920240"/>
-            <a:ext cx="8229600" cy="292608"/>
+            <a:ext cx="8229600" cy="310896"/>
           </a:xfrm>
           <a:prstGeom prst="rect">
             <a:avLst/>
@@ -2074,7 +2074,7 @@
               <a:buNone/>
             </a:pPr>
             <a:r>
-              <a:rPr lang="en-US" sz="1100" b="1" spc="300" kern="0" dirty="0">
+              <a:rPr lang="en-US" sz="1200" b="1" spc="300" kern="0" dirty="0">
                 <a:solidFill>
                   <a:srgbClr val="38BDF8"/>
                 </a:solidFill>
@@ -2084,7 +2084,7 @@
               </a:rPr>
               <a:t>BNI COMMUNITY CONNECTORS  ·  RIVER ARTS VENUE  ·  JULY 21, 2026</a:t>
             </a:r>
-            <a:endParaRPr lang="en-US" sz="1100" dirty="0"/>
+            <a:endParaRPr lang="en-US" sz="1200" dirty="0"/>
           </a:p>
         </p:txBody>
       </p:sp>
@@ -2271,9 +2271,9 @@
               <a:buNone/>
             </a:pPr>
             <a:r>
-              <a:rPr lang="en-US" sz="1200" dirty="0">
-                <a:solidFill>
-                  <a:srgbClr val="94A3B8"/>
+              <a:rPr lang="en-US" sz="1300" dirty="0">
+                <a:solidFill>
+                  <a:srgbClr val="E2E8F2"/>
                 </a:solidFill>
                 <a:latin typeface="Inter" pitchFamily="34" charset="0"/>
                 <a:ea typeface="Inter" pitchFamily="34" charset="-122"/>
@@ -2281,7 +2281,7 @@
               </a:rPr>
               <a:t>Synergy Telecom  ·  synergytelecom.org</a:t>
             </a:r>
-            <a:endParaRPr lang="en-US" sz="1200" dirty="0"/>
+            <a:endParaRPr lang="en-US" sz="1300" dirty="0"/>
           </a:p>
         </p:txBody>
       </p:sp>
@@ -2333,7 +2333,7 @@
         <p:spPr>
           <a:xfrm>
             <a:off x="822960" y="777240"/>
-            <a:ext cx="6400800" cy="292608"/>
+            <a:ext cx="6400800" cy="310896"/>
           </a:xfrm>
           <a:prstGeom prst="rect">
             <a:avLst/>
@@ -2349,7 +2349,7 @@
               <a:buNone/>
             </a:pPr>
             <a:r>
-              <a:rPr lang="en-US" sz="1100" b="1" spc="300" kern="0" dirty="0">
+              <a:rPr lang="en-US" sz="1200" b="1" spc="300" kern="0" dirty="0">
                 <a:solidFill>
                   <a:srgbClr val="38BDF8"/>
                 </a:solidFill>
@@ -2359,7 +2359,7 @@
               </a:rPr>
               <a:t>PROOF, NOT PROMISES</a:t>
             </a:r>
-            <a:endParaRPr lang="en-US" sz="1100" dirty="0"/>
+            <a:endParaRPr lang="en-US" sz="1200" dirty="0"/>
           </a:p>
         </p:txBody>
       </p:sp>
@@ -2510,9 +2510,9 @@
               <a:buNone/>
             </a:pPr>
             <a:r>
-              <a:rPr lang="en-US" sz="1100" dirty="0">
-                <a:solidFill>
-                  <a:srgbClr val="94A3B8"/>
+              <a:rPr lang="en-US" sz="1200" dirty="0">
+                <a:solidFill>
+                  <a:srgbClr val="E2E8F2"/>
                 </a:solidFill>
                 <a:latin typeface="Inter" pitchFamily="34" charset="0"/>
                 <a:ea typeface="Inter" pitchFamily="34" charset="-122"/>
@@ -2520,7 +2520,7 @@
               </a:rPr>
               <a:t>searches measured</a:t>
             </a:r>
-            <a:endParaRPr lang="en-US" sz="1100" dirty="0"/>
+            <a:endParaRPr lang="en-US" sz="1200" dirty="0"/>
           </a:p>
         </p:txBody>
       </p:sp>
@@ -2629,9 +2629,9 @@
               <a:buNone/>
             </a:pPr>
             <a:r>
-              <a:rPr lang="en-US" sz="1100" dirty="0">
-                <a:solidFill>
-                  <a:srgbClr val="94A3B8"/>
+              <a:rPr lang="en-US" sz="1200" dirty="0">
+                <a:solidFill>
+                  <a:srgbClr val="E2E8F2"/>
                 </a:solidFill>
                 <a:latin typeface="Inter" pitchFamily="34" charset="0"/>
                 <a:ea typeface="Inter" pitchFamily="34" charset="-122"/>
@@ -2639,7 +2639,7 @@
               </a:rPr>
               <a:t>on the shelf, top three</a:t>
             </a:r>
-            <a:endParaRPr lang="en-US" sz="1100" dirty="0"/>
+            <a:endParaRPr lang="en-US" sz="1200" dirty="0"/>
           </a:p>
         </p:txBody>
       </p:sp>
@@ -2748,9 +2748,9 @@
               <a:buNone/>
             </a:pPr>
             <a:r>
-              <a:rPr lang="en-US" sz="1100" dirty="0">
-                <a:solidFill>
-                  <a:srgbClr val="94A3B8"/>
+              <a:rPr lang="en-US" sz="1200" dirty="0">
+                <a:solidFill>
+                  <a:srgbClr val="E2E8F2"/>
                 </a:solidFill>
                 <a:latin typeface="Inter" pitchFamily="34" charset="0"/>
                 <a:ea typeface="Inter" pitchFamily="34" charset="-122"/>
@@ -2758,7 +2758,7 @@
               </a:rPr>
               <a:t>ranked number one</a:t>
             </a:r>
-            <a:endParaRPr lang="en-US" sz="1100" dirty="0"/>
+            <a:endParaRPr lang="en-US" sz="1200" dirty="0"/>
           </a:p>
         </p:txBody>
       </p:sp>
@@ -2787,9 +2787,9 @@
               <a:buNone/>
             </a:pPr>
             <a:r>
-              <a:rPr lang="en-US" sz="1250" dirty="0">
-                <a:solidFill>
-                  <a:srgbClr val="94A3B8"/>
+              <a:rPr lang="en-US" sz="1350" dirty="0">
+                <a:solidFill>
+                  <a:srgbClr val="E2E8F2"/>
                 </a:solidFill>
                 <a:latin typeface="Inter" pitchFamily="34" charset="0"/>
                 <a:ea typeface="Inter" pitchFamily="34" charset="-122"/>
@@ -2797,7 +2797,7 @@
               </a:rPr>
               <a:t>River Arts Venue  ·  Rome market  ·  measured July 19</a:t>
             </a:r>
-            <a:endParaRPr lang="en-US" sz="1250" dirty="0"/>
+            <a:endParaRPr lang="en-US" sz="1350" dirty="0"/>
           </a:p>
         </p:txBody>
       </p:sp>
@@ -2828,7 +2828,7 @@
               <a:buNone/>
             </a:pPr>
             <a:r>
-              <a:rPr lang="en-US" sz="1250" u="sng" dirty="0">
+              <a:rPr lang="en-US" sz="1350" u="sng" dirty="0">
                 <a:solidFill>
                   <a:srgbClr val="38BDF8"/>
                 </a:solidFill>
@@ -2845,7 +2845,7 @@
               </a:rPr>
               <a:t>forge-dev-studio.github.io/client-reports/river-arts-venue</a:t>
             </a:r>
-            <a:endParaRPr lang="en-US" sz="1250" dirty="0"/>
+            <a:endParaRPr lang="en-US" sz="1350" dirty="0"/>
           </a:p>
         </p:txBody>
       </p:sp>
@@ -2877,9 +2877,9 @@
               <a:buNone/>
             </a:pPr>
             <a:r>
-              <a:rPr lang="en-US" sz="1350" dirty="0">
-                <a:solidFill>
-                  <a:srgbClr val="CBD5E1"/>
+              <a:rPr lang="en-US" sz="1450" dirty="0">
+                <a:solidFill>
+                  <a:srgbClr val="E2E8F2"/>
                 </a:solidFill>
                 <a:latin typeface="Inter" pitchFamily="34" charset="0"/>
                 <a:ea typeface="Inter" pitchFamily="34" charset="-122"/>
@@ -2887,7 +2887,7 @@
               </a:rPr>
               <a:t>The edges show up too: wedding venue at 6, birthday party and rehearsal dinner at 5. Finding those is the point of an audit.</a:t>
             </a:r>
-            <a:endParaRPr lang="en-US" sz="1350" dirty="0"/>
+            <a:endParaRPr lang="en-US" sz="1450" dirty="0"/>
           </a:p>
         </p:txBody>
       </p:sp>
@@ -3177,7 +3177,7 @@
             <a:r>
               <a:rPr lang="en-US" sz="1200" dirty="0">
                 <a:solidFill>
-                  <a:srgbClr val="CBD5E1"/>
+                  <a:srgbClr val="E2E8F2"/>
                 </a:solidFill>
                 <a:latin typeface="Inter" pitchFamily="34" charset="0"/>
                 <a:ea typeface="Inter" pitchFamily="34" charset="-122"/>
@@ -3376,7 +3376,7 @@
             <a:r>
               <a:rPr lang="en-US" sz="1200" dirty="0">
                 <a:solidFill>
-                  <a:srgbClr val="CBD5E1"/>
+                  <a:srgbClr val="E2E8F2"/>
                 </a:solidFill>
                 <a:latin typeface="Inter" pitchFamily="34" charset="0"/>
                 <a:ea typeface="Inter" pitchFamily="34" charset="-122"/>
@@ -3575,7 +3575,7 @@
             <a:r>
               <a:rPr lang="en-US" sz="1200" dirty="0">
                 <a:solidFill>
-                  <a:srgbClr val="CBD5E1"/>
+                  <a:srgbClr val="E2E8F2"/>
                 </a:solidFill>
                 <a:latin typeface="Inter" pitchFamily="34" charset="0"/>
                 <a:ea typeface="Inter" pitchFamily="34" charset="-122"/>
@@ -3790,9 +3790,9 @@
               <a:buNone/>
             </a:pPr>
             <a:r>
-              <a:rPr lang="en-US" sz="1250" dirty="0">
-                <a:solidFill>
-                  <a:srgbClr val="94A3B8"/>
+              <a:rPr lang="en-US" sz="1350" dirty="0">
+                <a:solidFill>
+                  <a:srgbClr val="E2E8F2"/>
                 </a:solidFill>
                 <a:latin typeface="Inter" pitchFamily="34" charset="0"/>
                 <a:ea typeface="Inter" pitchFamily="34" charset="-122"/>
@@ -3800,7 +3800,7 @@
               </a:rPr>
               <a:t>member businesses</a:t>
             </a:r>
-            <a:endParaRPr lang="en-US" sz="1250" dirty="0"/>
+            <a:endParaRPr lang="en-US" sz="1350" dirty="0"/>
           </a:p>
         </p:txBody>
       </p:sp>
@@ -3906,9 +3906,9 @@
               <a:buNone/>
             </a:pPr>
             <a:r>
-              <a:rPr lang="en-US" sz="1250" dirty="0">
-                <a:solidFill>
-                  <a:srgbClr val="94A3B8"/>
+              <a:rPr lang="en-US" sz="1350" dirty="0">
+                <a:solidFill>
+                  <a:srgbClr val="E2E8F2"/>
                 </a:solidFill>
                 <a:latin typeface="Inter" pitchFamily="34" charset="0"/>
                 <a:ea typeface="Inter" pitchFamily="34" charset="-122"/>
@@ -3916,7 +3916,7 @@
               </a:rPr>
               <a:t>search phrases each</a:t>
             </a:r>
-            <a:endParaRPr lang="en-US" sz="1250" dirty="0"/>
+            <a:endParaRPr lang="en-US" sz="1350" dirty="0"/>
           </a:p>
         </p:txBody>
       </p:sp>
@@ -4022,9 +4022,9 @@
               <a:buNone/>
             </a:pPr>
             <a:r>
-              <a:rPr lang="en-US" sz="1250" dirty="0">
-                <a:solidFill>
-                  <a:srgbClr val="94A3B8"/>
+              <a:rPr lang="en-US" sz="1350" dirty="0">
+                <a:solidFill>
+                  <a:srgbClr val="E2E8F2"/>
                 </a:solidFill>
                 <a:latin typeface="Inter" pitchFamily="34" charset="0"/>
                 <a:ea typeface="Inter" pitchFamily="34" charset="-122"/>
@@ -4032,7 +4032,7 @@
               </a:rPr>
               <a:t>radius around you</a:t>
             </a:r>
-            <a:endParaRPr lang="en-US" sz="1250" dirty="0"/>
+            <a:endParaRPr lang="en-US" sz="1350" dirty="0"/>
           </a:p>
         </p:txBody>
       </p:sp>
@@ -4138,9 +4138,9 @@
               <a:buNone/>
             </a:pPr>
             <a:r>
-              <a:rPr lang="en-US" sz="1250" dirty="0">
-                <a:solidFill>
-                  <a:srgbClr val="94A3B8"/>
+              <a:rPr lang="en-US" sz="1350" dirty="0">
+                <a:solidFill>
+                  <a:srgbClr val="E2E8F2"/>
                 </a:solidFill>
                 <a:latin typeface="Inter" pitchFamily="34" charset="0"/>
                 <a:ea typeface="Inter" pitchFamily="34" charset="-122"/>
@@ -4148,7 +4148,7 @@
               </a:rPr>
               <a:t>real Google searches</a:t>
             </a:r>
-            <a:endParaRPr lang="en-US" sz="1250" dirty="0"/>
+            <a:endParaRPr lang="en-US" sz="1350" dirty="0"/>
           </a:p>
         </p:txBody>
       </p:sp>
@@ -4179,7 +4179,7 @@
             <a:r>
               <a:rPr lang="en-US" sz="1600" i="1" dirty="0">
                 <a:solidFill>
-                  <a:srgbClr val="CBD5E1"/>
+                  <a:srgbClr val="E2E8F2"/>
                 </a:solidFill>
                 <a:latin typeface="Inter" pitchFamily="34" charset="0"/>
                 <a:ea typeface="Inter" pitchFamily="34" charset="-122"/>
@@ -4239,7 +4239,7 @@
         <p:spPr>
           <a:xfrm>
             <a:off x="822960" y="1051560"/>
-            <a:ext cx="6400800" cy="292608"/>
+            <a:ext cx="6400800" cy="310896"/>
           </a:xfrm>
           <a:prstGeom prst="rect">
             <a:avLst/>
@@ -4255,7 +4255,7 @@
               <a:buNone/>
             </a:pPr>
             <a:r>
-              <a:rPr lang="en-US" sz="1100" b="1" spc="300" kern="0" dirty="0">
+              <a:rPr lang="en-US" sz="1200" b="1" spc="300" kern="0" dirty="0">
                 <a:solidFill>
                   <a:srgbClr val="38BDF8"/>
                 </a:solidFill>
@@ -4265,7 +4265,7 @@
               </a:rPr>
               <a:t>THIS MORNING</a:t>
             </a:r>
-            <a:endParaRPr lang="en-US" sz="1100" dirty="0"/>
+            <a:endParaRPr lang="en-US" sz="1200" dirty="0"/>
           </a:p>
         </p:txBody>
       </p:sp>
@@ -4339,9 +4339,9 @@
               <a:buNone/>
             </a:pPr>
             <a:r>
-              <a:rPr lang="en-US" sz="1550" dirty="0">
-                <a:solidFill>
-                  <a:srgbClr val="CBD5E1"/>
+              <a:rPr lang="en-US" sz="1600" dirty="0">
+                <a:solidFill>
+                  <a:srgbClr val="E2E8F2"/>
                 </a:solidFill>
                 <a:latin typeface="Inter" pitchFamily="34" charset="0"/>
                 <a:ea typeface="Inter" pitchFamily="34" charset="-122"/>
@@ -4349,7 +4349,7 @@
               </a:rPr>
               <a:t>Every member gets a personalized audit of their own business. Yours, not a template. Read it in five minutes.</a:t>
             </a:r>
-            <a:endParaRPr lang="en-US" sz="1550" dirty="0"/>
+            <a:endParaRPr lang="en-US" sz="1600" dirty="0"/>
           </a:p>
         </p:txBody>
       </p:sp>
@@ -4492,7 +4492,7 @@
         <p:spPr>
           <a:xfrm>
             <a:off x="2240280" y="4370832"/>
-            <a:ext cx="5852160" cy="365760"/>
+            <a:ext cx="6172200" cy="365760"/>
           </a:xfrm>
           <a:prstGeom prst="rect">
             <a:avLst/>
@@ -4508,9 +4508,9 @@
               <a:buNone/>
             </a:pPr>
             <a:r>
-              <a:rPr lang="en-US" sz="1300" dirty="0">
-                <a:solidFill>
-                  <a:srgbClr val="CBD5E1"/>
+              <a:rPr lang="en-US" sz="1350" dirty="0">
+                <a:solidFill>
+                  <a:srgbClr val="E2E8F2"/>
                 </a:solidFill>
                 <a:latin typeface="Inter" pitchFamily="34" charset="0"/>
                 <a:ea typeface="Inter" pitchFamily="34" charset="-122"/>
@@ -4518,7 +4518,7 @@
               </a:rPr>
               <a:t>Where you own the shelf  ·  where you are on the edge  ·  three clear actions</a:t>
             </a:r>
-            <a:endParaRPr lang="en-US" sz="1300" dirty="0"/>
+            <a:endParaRPr lang="en-US" sz="1350" dirty="0"/>
           </a:p>
         </p:txBody>
       </p:sp>
@@ -4608,9 +4608,9 @@
               <a:buNone/>
             </a:pPr>
             <a:r>
-              <a:rPr lang="en-US" sz="1300" i="1" dirty="0">
-                <a:solidFill>
-                  <a:srgbClr val="94A3B8"/>
+              <a:rPr lang="en-US" sz="1400" i="1" dirty="0">
+                <a:solidFill>
+                  <a:srgbClr val="E2E8F2"/>
                 </a:solidFill>
                 <a:latin typeface="Inter" pitchFamily="34" charset="0"/>
                 <a:ea typeface="Inter" pitchFamily="34" charset="-122"/>
@@ -4618,7 +4618,7 @@
               </a:rPr>
               <a:t>Check the email address your chapter roster has on file.</a:t>
             </a:r>
-            <a:endParaRPr lang="en-US" sz="1300" dirty="0"/>
+            <a:endParaRPr lang="en-US" sz="1400" dirty="0"/>
           </a:p>
         </p:txBody>
       </p:sp>
@@ -4844,9 +4844,9 @@
               <a:buNone/>
             </a:pPr>
             <a:r>
-              <a:rPr lang="en-US" sz="1300" dirty="0">
-                <a:solidFill>
-                  <a:srgbClr val="CBD5E1"/>
+              <a:rPr lang="en-US" sz="1400" dirty="0">
+                <a:solidFill>
+                  <a:srgbClr val="E2E8F2"/>
                 </a:solidFill>
                 <a:latin typeface="Inter" pitchFamily="34" charset="0"/>
                 <a:ea typeface="Inter" pitchFamily="34" charset="-122"/>
@@ -4854,7 +4854,7 @@
               </a:rPr>
               <a:t>Synergy Telecom  ·  synergytelecom.org</a:t>
             </a:r>
-            <a:endParaRPr lang="en-US" sz="1300" dirty="0"/>
+            <a:endParaRPr lang="en-US" sz="1400" dirty="0"/>
           </a:p>
         </p:txBody>
       </p:sp>
@@ -4883,9 +4883,9 @@
               <a:buNone/>
             </a:pPr>
             <a:r>
-              <a:rPr lang="en-US" sz="1300" dirty="0">
-                <a:solidFill>
-                  <a:srgbClr val="94A3B8"/>
+              <a:rPr lang="en-US" sz="1400" dirty="0">
+                <a:solidFill>
+                  <a:srgbClr val="E2E8F2"/>
                 </a:solidFill>
                 <a:latin typeface="Inter" pitchFamily="34" charset="0"/>
                 <a:ea typeface="Inter" pitchFamily="34" charset="-122"/>
@@ -4893,7 +4893,7 @@
               </a:rPr>
               <a:t>Eric@synergytelecom.org</a:t>
             </a:r>
-            <a:endParaRPr lang="en-US" sz="1300" dirty="0"/>
+            <a:endParaRPr lang="en-US" sz="1400" dirty="0"/>
           </a:p>
         </p:txBody>
       </p:sp>
@@ -4922,11 +4922,9 @@
               <a:buNone/>
             </a:pPr>
             <a:r>
-              <a:rPr lang="en-US" sz="1100" dirty="0">
-                <a:solidFill>
-                  <a:srgbClr val="94A3B8">
-                    <a:alpha val="80000"/>
-                  </a:srgbClr>
+              <a:rPr lang="en-US" sz="1200" dirty="0">
+                <a:solidFill>
+                  <a:srgbClr val="B3BFD3"/>
                 </a:solidFill>
                 <a:latin typeface="Inter" pitchFamily="34" charset="0"/>
                 <a:ea typeface="Inter" pitchFamily="34" charset="-122"/>
@@ -4934,7 +4932,7 @@
               </a:rPr>
               <a:t>Audit reports built with Forge Dev Studio</a:t>
             </a:r>
-            <a:endParaRPr lang="en-US" sz="1100" dirty="0"/>
+            <a:endParaRPr lang="en-US" sz="1200" dirty="0"/>
           </a:p>
         </p:txBody>
       </p:sp>
@@ -5061,7 +5059,7 @@
         <p:spPr>
           <a:xfrm>
             <a:off x="822960" y="777240"/>
-            <a:ext cx="6400800" cy="292608"/>
+            <a:ext cx="6400800" cy="310896"/>
           </a:xfrm>
           <a:prstGeom prst="rect">
             <a:avLst/>
@@ -5077,7 +5075,7 @@
               <a:buNone/>
             </a:pPr>
             <a:r>
-              <a:rPr lang="en-US" sz="1100" b="1" spc="300" kern="0" dirty="0">
+              <a:rPr lang="en-US" sz="1200" b="1" spc="300" kern="0" dirty="0">
                 <a:solidFill>
                   <a:srgbClr val="38BDF8"/>
                 </a:solidFill>
@@ -5087,7 +5085,7 @@
               </a:rPr>
               <a:t>HOW CUSTOMERS FIND YOU</a:t>
             </a:r>
-            <a:endParaRPr lang="en-US" sz="1100" dirty="0"/>
+            <a:endParaRPr lang="en-US" sz="1200" dirty="0"/>
           </a:p>
         </p:txBody>
       </p:sp>
@@ -5181,9 +5179,9 @@
               <a:buNone/>
             </a:pPr>
             <a:r>
-              <a:rPr lang="en-US" sz="1500" dirty="0">
-                <a:solidFill>
-                  <a:srgbClr val="CBD5E1"/>
+              <a:rPr lang="en-US" sz="1600" dirty="0">
+                <a:solidFill>
+                  <a:srgbClr val="E2E8F2"/>
                 </a:solidFill>
                 <a:latin typeface="Inter" pitchFamily="34" charset="0"/>
                 <a:ea typeface="Inter" pitchFamily="34" charset="-122"/>
@@ -5191,7 +5189,7 @@
               </a:rPr>
               <a:t>When someone needs what you do, they do not wander the internet hoping to bump into you. They type a question and pick from the first answers they see.</a:t>
             </a:r>
-            <a:endParaRPr lang="en-US" sz="1500" dirty="0"/>
+            <a:endParaRPr lang="en-US" sz="1600" dirty="0"/>
           </a:p>
         </p:txBody>
       </p:sp>
@@ -5479,9 +5477,9 @@
               <a:buNone/>
             </a:pPr>
             <a:r>
-              <a:rPr lang="en-US" sz="1250" i="1" dirty="0">
-                <a:solidFill>
-                  <a:srgbClr val="94A3B8"/>
+              <a:rPr lang="en-US" sz="1350" i="1" dirty="0">
+                <a:solidFill>
+                  <a:srgbClr val="E2E8F2"/>
                 </a:solidFill>
                 <a:latin typeface="Inter" pitchFamily="34" charset="0"/>
                 <a:ea typeface="Inter" pitchFamily="34" charset="-122"/>
@@ -5489,7 +5487,7 @@
               </a:rPr>
               <a:t>The first answers win. The rest are invisible.</a:t>
             </a:r>
-            <a:endParaRPr lang="en-US" sz="1250" dirty="0"/>
+            <a:endParaRPr lang="en-US" sz="1350" dirty="0"/>
           </a:p>
         </p:txBody>
       </p:sp>
@@ -5541,7 +5539,7 @@
         <p:spPr>
           <a:xfrm>
             <a:off x="822960" y="777240"/>
-            <a:ext cx="6400800" cy="292608"/>
+            <a:ext cx="6400800" cy="310896"/>
           </a:xfrm>
           <a:prstGeom prst="rect">
             <a:avLst/>
@@ -5557,7 +5555,7 @@
               <a:buNone/>
             </a:pPr>
             <a:r>
-              <a:rPr lang="en-US" sz="1100" b="1" spc="300" kern="0" dirty="0">
+              <a:rPr lang="en-US" sz="1200" b="1" spc="300" kern="0" dirty="0">
                 <a:solidFill>
                   <a:srgbClr val="38BDF8"/>
                 </a:solidFill>
@@ -5567,7 +5565,7 @@
               </a:rPr>
               <a:t>THE PICTURE</a:t>
             </a:r>
-            <a:endParaRPr lang="en-US" sz="1100" dirty="0"/>
+            <a:endParaRPr lang="en-US" sz="1200" dirty="0"/>
           </a:p>
         </p:txBody>
       </p:sp>
@@ -5641,9 +5639,9 @@
               <a:buNone/>
             </a:pPr>
             <a:r>
-              <a:rPr lang="en-US" sz="1500" dirty="0">
-                <a:solidFill>
-                  <a:srgbClr val="CBD5E1"/>
+              <a:rPr lang="en-US" sz="1600" dirty="0">
+                <a:solidFill>
+                  <a:srgbClr val="E2E8F2"/>
                 </a:solidFill>
                 <a:latin typeface="Inter" pitchFamily="34" charset="0"/>
                 <a:ea typeface="Inter" pitchFamily="34" charset="-122"/>
@@ -5651,7 +5649,7 @@
               </a:rPr>
               <a:t>Every business, every article, every menu, every review. All of it shelved in one impossibly large building.</a:t>
             </a:r>
-            <a:endParaRPr lang="en-US" sz="1500" dirty="0"/>
+            <a:endParaRPr lang="en-US" sz="1600" dirty="0"/>
           </a:p>
           <a:p>
             <a:pPr algn="l" indent="0" marL="0">
@@ -5660,7 +5658,7 @@
               </a:lnSpc>
               <a:buNone/>
             </a:pPr>
-            <a:endParaRPr lang="en-US" sz="1500" dirty="0"/>
+            <a:endParaRPr lang="en-US" sz="1600" dirty="0"/>
           </a:p>
           <a:p>
             <a:pPr algn="l" indent="0" marL="0">
@@ -5670,9 +5668,9 @@
               <a:buNone/>
             </a:pPr>
             <a:r>
-              <a:rPr lang="en-US" sz="1500" dirty="0">
-                <a:solidFill>
-                  <a:srgbClr val="CBD5E1"/>
+              <a:rPr lang="en-US" sz="1600" dirty="0">
+                <a:solidFill>
+                  <a:srgbClr val="E2E8F2"/>
                 </a:solidFill>
                 <a:latin typeface="Inter" pitchFamily="34" charset="0"/>
                 <a:ea typeface="Inter" pitchFamily="34" charset="-122"/>
@@ -5680,7 +5678,7 @@
               </a:rPr>
               <a:t>Your website is in there right now.</a:t>
             </a:r>
-            <a:endParaRPr lang="en-US" sz="1500" dirty="0"/>
+            <a:endParaRPr lang="en-US" sz="1600" dirty="0"/>
           </a:p>
         </p:txBody>
       </p:sp>
@@ -6333,9 +6331,9 @@
               <a:buNone/>
             </a:pPr>
             <a:r>
-              <a:rPr lang="en-US" sz="1200" dirty="0">
-                <a:solidFill>
-                  <a:srgbClr val="94A3B8"/>
+              <a:rPr lang="en-US" sz="1400" dirty="0">
+                <a:solidFill>
+                  <a:srgbClr val="E2E8F2"/>
                 </a:solidFill>
                 <a:latin typeface="Inter" pitchFamily="34" charset="0"/>
                 <a:ea typeface="Inter" pitchFamily="34" charset="-122"/>
@@ -6343,7 +6341,7 @@
               </a:rPr>
               <a:t>your book</a:t>
             </a:r>
-            <a:endParaRPr lang="en-US" sz="1200" dirty="0"/>
+            <a:endParaRPr lang="en-US" sz="1400" dirty="0"/>
           </a:p>
         </p:txBody>
       </p:sp>
@@ -6395,7 +6393,7 @@
         <p:spPr>
           <a:xfrm>
             <a:off x="822960" y="777240"/>
-            <a:ext cx="6400800" cy="292608"/>
+            <a:ext cx="6400800" cy="310896"/>
           </a:xfrm>
           <a:prstGeom prst="rect">
             <a:avLst/>
@@ -6411,7 +6409,7 @@
               <a:buNone/>
             </a:pPr>
             <a:r>
-              <a:rPr lang="en-US" sz="1100" b="1" spc="300" kern="0" dirty="0">
+              <a:rPr lang="en-US" sz="1200" b="1" spc="300" kern="0" dirty="0">
                 <a:solidFill>
                   <a:srgbClr val="38BDF8"/>
                 </a:solidFill>
@@ -6421,7 +6419,7 @@
               </a:rPr>
               <a:t>WHO DECIDES</a:t>
             </a:r>
-            <a:endParaRPr lang="en-US" sz="1100" dirty="0"/>
+            <a:endParaRPr lang="en-US" sz="1200" dirty="0"/>
           </a:p>
         </p:txBody>
       </p:sp>
@@ -6495,9 +6493,9 @@
               <a:buNone/>
             </a:pPr>
             <a:r>
-              <a:rPr lang="en-US" sz="1500" dirty="0">
-                <a:solidFill>
-                  <a:srgbClr val="CBD5E1"/>
+              <a:rPr lang="en-US" sz="1600" dirty="0">
+                <a:solidFill>
+                  <a:srgbClr val="E2E8F2"/>
                 </a:solidFill>
                 <a:latin typeface="Inter" pitchFamily="34" charset="0"/>
                 <a:ea typeface="Inter" pitchFamily="34" charset="-122"/>
@@ -6505,7 +6503,7 @@
               </a:rPr>
               <a:t>Nobody searches the stacks. They ask the librarian, and the librarian hands over three books first. Almost everyone takes one of those three.</a:t>
             </a:r>
-            <a:endParaRPr lang="en-US" sz="1500" dirty="0"/>
+            <a:endParaRPr lang="en-US" sz="1600" dirty="0"/>
           </a:p>
         </p:txBody>
       </p:sp>
@@ -6614,9 +6612,9 @@
               <a:buNone/>
             </a:pPr>
             <a:r>
-              <a:rPr lang="en-US" sz="1300" i="1" dirty="0">
-                <a:solidFill>
-                  <a:srgbClr val="94A3B8"/>
+              <a:rPr lang="en-US" sz="1400" i="1" dirty="0">
+                <a:solidFill>
+                  <a:srgbClr val="E2E8F2"/>
                 </a:solidFill>
                 <a:latin typeface="Inter" pitchFamily="34" charset="0"/>
                 <a:ea typeface="Inter" pitchFamily="34" charset="-122"/>
@@ -6624,7 +6622,7 @@
               </a:rPr>
               <a:t>someone asks: best hvac company near me</a:t>
             </a:r>
-            <a:endParaRPr lang="en-US" sz="1300" dirty="0"/>
+            <a:endParaRPr lang="en-US" sz="1400" dirty="0"/>
           </a:p>
         </p:txBody>
       </p:sp>
@@ -7115,7 +7113,7 @@
         <p:spPr>
           <a:xfrm>
             <a:off x="822960" y="777240"/>
-            <a:ext cx="6400800" cy="292608"/>
+            <a:ext cx="6400800" cy="310896"/>
           </a:xfrm>
           <a:prstGeom prst="rect">
             <a:avLst/>
@@ -7131,7 +7129,7 @@
               <a:buNone/>
             </a:pPr>
             <a:r>
-              <a:rPr lang="en-US" sz="1100" b="1" spc="300" kern="0" dirty="0">
+              <a:rPr lang="en-US" sz="1200" b="1" spc="300" kern="0" dirty="0">
                 <a:solidFill>
                   <a:srgbClr val="38BDF8"/>
                 </a:solidFill>
@@ -7141,7 +7139,7 @@
               </a:rPr>
               <a:t>PART ONE  ·  YOUR BOOK</a:t>
             </a:r>
-            <a:endParaRPr lang="en-US" sz="1100" dirty="0"/>
+            <a:endParaRPr lang="en-US" sz="1200" dirty="0"/>
           </a:p>
         </p:txBody>
       </p:sp>
@@ -7265,7 +7263,7 @@
               <a:buNone/>
             </a:pPr>
             <a:r>
-              <a:rPr lang="en-US" sz="1650" b="1" dirty="0">
+              <a:rPr lang="en-US" sz="1700" b="1" dirty="0">
                 <a:solidFill>
                   <a:srgbClr val="F8FAFC"/>
                 </a:solidFill>
@@ -7275,7 +7273,7 @@
               </a:rPr>
               <a:t>The cover</a:t>
             </a:r>
-            <a:endParaRPr lang="en-US" sz="1650" dirty="0"/>
+            <a:endParaRPr lang="en-US" sz="1700" dirty="0"/>
           </a:p>
         </p:txBody>
       </p:sp>
@@ -7287,7 +7285,7 @@
         </p:nvSpPr>
         <p:spPr>
           <a:xfrm>
-            <a:off x="1627632" y="2642616"/>
+            <a:off x="1627632" y="2660904"/>
             <a:ext cx="5230368" cy="685800"/>
           </a:xfrm>
           <a:prstGeom prst="rect">
@@ -7307,9 +7305,9 @@
               <a:buNone/>
             </a:pPr>
             <a:r>
-              <a:rPr lang="en-US" sz="1300" dirty="0">
-                <a:solidFill>
-                  <a:srgbClr val="94A3B8"/>
+              <a:rPr lang="en-US" sz="1400" dirty="0">
+                <a:solidFill>
+                  <a:srgbClr val="E2E8F2"/>
                 </a:solidFill>
                 <a:latin typeface="Inter" pitchFamily="34" charset="0"/>
                 <a:ea typeface="Inter" pitchFamily="34" charset="-122"/>
@@ -7317,7 +7315,7 @@
               </a:rPr>
               <a:t>Says what you do and where you do it. A vague cover never gets opened.</a:t>
             </a:r>
-            <a:endParaRPr lang="en-US" sz="1300" dirty="0"/>
+            <a:endParaRPr lang="en-US" sz="1400" dirty="0"/>
           </a:p>
         </p:txBody>
       </p:sp>
@@ -7399,7 +7397,7 @@
               <a:buNone/>
             </a:pPr>
             <a:r>
-              <a:rPr lang="en-US" sz="1650" b="1" dirty="0">
+              <a:rPr lang="en-US" sz="1700" b="1" dirty="0">
                 <a:solidFill>
                   <a:srgbClr val="F8FAFC"/>
                 </a:solidFill>
@@ -7409,7 +7407,7 @@
               </a:rPr>
               <a:t>The chapters</a:t>
             </a:r>
-            <a:endParaRPr lang="en-US" sz="1650" dirty="0"/>
+            <a:endParaRPr lang="en-US" sz="1700" dirty="0"/>
           </a:p>
         </p:txBody>
       </p:sp>
@@ -7421,7 +7419,7 @@
         </p:nvSpPr>
         <p:spPr>
           <a:xfrm>
-            <a:off x="1627632" y="3785616"/>
+            <a:off x="1627632" y="3803904"/>
             <a:ext cx="5230368" cy="685800"/>
           </a:xfrm>
           <a:prstGeom prst="rect">
@@ -7441,9 +7439,9 @@
               <a:buNone/>
             </a:pPr>
             <a:r>
-              <a:rPr lang="en-US" sz="1300" dirty="0">
-                <a:solidFill>
-                  <a:srgbClr val="94A3B8"/>
+              <a:rPr lang="en-US" sz="1400" dirty="0">
+                <a:solidFill>
+                  <a:srgbClr val="E2E8F2"/>
                 </a:solidFill>
                 <a:latin typeface="Inter" pitchFamily="34" charset="0"/>
                 <a:ea typeface="Inter" pitchFamily="34" charset="-122"/>
@@ -7451,7 +7449,7 @@
               </a:rPr>
               <a:t>Pages that answer the questions customers actually ask. One page per question.</a:t>
             </a:r>
-            <a:endParaRPr lang="en-US" sz="1300" dirty="0"/>
+            <a:endParaRPr lang="en-US" sz="1400" dirty="0"/>
           </a:p>
         </p:txBody>
       </p:sp>
@@ -7533,7 +7531,7 @@
               <a:buNone/>
             </a:pPr>
             <a:r>
-              <a:rPr lang="en-US" sz="1650" b="1" dirty="0">
+              <a:rPr lang="en-US" sz="1700" b="1" dirty="0">
                 <a:solidFill>
                   <a:srgbClr val="F8FAFC"/>
                 </a:solidFill>
@@ -7543,7 +7541,7 @@
               </a:rPr>
               <a:t>More than a business card</a:t>
             </a:r>
-            <a:endParaRPr lang="en-US" sz="1650" dirty="0"/>
+            <a:endParaRPr lang="en-US" sz="1700" dirty="0"/>
           </a:p>
         </p:txBody>
       </p:sp>
@@ -7555,7 +7553,7 @@
         </p:nvSpPr>
         <p:spPr>
           <a:xfrm>
-            <a:off x="1627632" y="4928616"/>
+            <a:off x="1627632" y="4946904"/>
             <a:ext cx="5230368" cy="685800"/>
           </a:xfrm>
           <a:prstGeom prst="rect">
@@ -7575,9 +7573,9 @@
               <a:buNone/>
             </a:pPr>
             <a:r>
-              <a:rPr lang="en-US" sz="1300" dirty="0">
-                <a:solidFill>
-                  <a:srgbClr val="94A3B8"/>
+              <a:rPr lang="en-US" sz="1400" dirty="0">
+                <a:solidFill>
+                  <a:srgbClr val="E2E8F2"/>
                 </a:solidFill>
                 <a:latin typeface="Inter" pitchFamily="34" charset="0"/>
                 <a:ea typeface="Inter" pitchFamily="34" charset="-122"/>
@@ -7585,7 +7583,7 @@
               </a:rPr>
               <a:t>A one page site is a card on a shelf. Librarians recommend books.</a:t>
             </a:r>
-            <a:endParaRPr lang="en-US" sz="1300" dirty="0"/>
+            <a:endParaRPr lang="en-US" sz="1400" dirty="0"/>
           </a:p>
         </p:txBody>
       </p:sp>
@@ -7893,7 +7891,7 @@
         <p:spPr>
           <a:xfrm>
             <a:off x="822960" y="777240"/>
-            <a:ext cx="6400800" cy="292608"/>
+            <a:ext cx="6400800" cy="310896"/>
           </a:xfrm>
           <a:prstGeom prst="rect">
             <a:avLst/>
@@ -7909,7 +7907,7 @@
               <a:buNone/>
             </a:pPr>
             <a:r>
-              <a:rPr lang="en-US" sz="1100" b="1" spc="300" kern="0" dirty="0">
+              <a:rPr lang="en-US" sz="1200" b="1" spc="300" kern="0" dirty="0">
                 <a:solidFill>
                   <a:srgbClr val="38BDF8"/>
                 </a:solidFill>
@@ -7917,9 +7915,9 @@
                 <a:ea typeface="Inter" pitchFamily="34" charset="-122"/>
                 <a:cs typeface="Inter" pitchFamily="34" charset="-120"/>
               </a:rPr>
-              <a:t>PART TWO  ·  YOUR FLYERS</a:t>
-            </a:r>
-            <a:endParaRPr lang="en-US" sz="1100" dirty="0"/>
+              <a:t>PART TWO  ·  YOUR REFERENCES</a:t>
+            </a:r>
+            <a:endParaRPr lang="en-US" sz="1200" dirty="0"/>
           </a:p>
         </p:txBody>
       </p:sp>
@@ -7959,7 +7957,7 @@
                 <a:ea typeface="Outfit" pitchFamily="34" charset="-122"/>
                 <a:cs typeface="Outfit" pitchFamily="34" charset="-120"/>
               </a:rPr>
-              <a:t>The flyer: your evidence around town.</a:t>
+              <a:t>Your references: who vouches for you.</a:t>
             </a:r>
             <a:endParaRPr lang="en-US" sz="3400" dirty="0"/>
           </a:p>
@@ -8043,7 +8041,7 @@
               <a:buNone/>
             </a:pPr>
             <a:r>
-              <a:rPr lang="en-US" sz="1650" b="1" dirty="0">
+              <a:rPr lang="en-US" sz="1700" b="1" dirty="0">
                 <a:solidFill>
                   <a:srgbClr val="F8FAFC"/>
                 </a:solidFill>
@@ -8051,9 +8049,9 @@
                 <a:ea typeface="Outfit" pitchFamily="34" charset="-122"/>
                 <a:cs typeface="Outfit" pitchFamily="34" charset="-120"/>
               </a:rPr>
-              <a:t>Your listings</a:t>
-            </a:r>
-            <a:endParaRPr lang="en-US" sz="1650" dirty="0"/>
+              <a:t>Your card in the catalog</a:t>
+            </a:r>
+            <a:endParaRPr lang="en-US" sz="1700" dirty="0"/>
           </a:p>
         </p:txBody>
       </p:sp>
@@ -8065,7 +8063,7 @@
         </p:nvSpPr>
         <p:spPr>
           <a:xfrm>
-            <a:off x="1627632" y="2642616"/>
+            <a:off x="1627632" y="2660904"/>
             <a:ext cx="5047488" cy="685800"/>
           </a:xfrm>
           <a:prstGeom prst="rect">
@@ -8085,17 +8083,17 @@
               <a:buNone/>
             </a:pPr>
             <a:r>
-              <a:rPr lang="en-US" sz="1300" dirty="0">
-                <a:solidFill>
-                  <a:srgbClr val="94A3B8"/>
+              <a:rPr lang="en-US" sz="1400" dirty="0">
+                <a:solidFill>
+                  <a:srgbClr val="E2E8F2"/>
                 </a:solidFill>
                 <a:latin typeface="Inter" pitchFamily="34" charset="0"/>
                 <a:ea typeface="Inter" pitchFamily="34" charset="-122"/>
                 <a:cs typeface="Inter" pitchFamily="34" charset="-120"/>
               </a:rPr>
-              <a:t>Directories and maps. The catalog cards that prove you exist, and where.</a:t>
-            </a:r>
-            <a:endParaRPr lang="en-US" sz="1300" dirty="0"/>
+              <a:t>Directories and maps. Every listing of your business around the library.</a:t>
+            </a:r>
+            <a:endParaRPr lang="en-US" sz="1400" dirty="0"/>
           </a:p>
         </p:txBody>
       </p:sp>
@@ -8177,7 +8175,7 @@
               <a:buNone/>
             </a:pPr>
             <a:r>
-              <a:rPr lang="en-US" sz="1650" b="1" dirty="0">
+              <a:rPr lang="en-US" sz="1700" b="1" dirty="0">
                 <a:solidFill>
                   <a:srgbClr val="F8FAFC"/>
                 </a:solidFill>
@@ -8185,9 +8183,9 @@
                 <a:ea typeface="Outfit" pitchFamily="34" charset="-122"/>
                 <a:cs typeface="Outfit" pitchFamily="34" charset="-120"/>
               </a:rPr>
-              <a:t>Others pointing at you</a:t>
-            </a:r>
-            <a:endParaRPr lang="en-US" sz="1650" dirty="0"/>
+              <a:t>Cited by other books</a:t>
+            </a:r>
+            <a:endParaRPr lang="en-US" sz="1700" dirty="0"/>
           </a:p>
         </p:txBody>
       </p:sp>
@@ -8199,7 +8197,7 @@
         </p:nvSpPr>
         <p:spPr>
           <a:xfrm>
-            <a:off x="1627632" y="3785616"/>
+            <a:off x="1627632" y="3803904"/>
             <a:ext cx="5047488" cy="685800"/>
           </a:xfrm>
           <a:prstGeom prst="rect">
@@ -8219,17 +8217,17 @@
               <a:buNone/>
             </a:pPr>
             <a:r>
-              <a:rPr lang="en-US" sz="1300" dirty="0">
-                <a:solidFill>
-                  <a:srgbClr val="94A3B8"/>
+              <a:rPr lang="en-US" sz="1400" dirty="0">
+                <a:solidFill>
+                  <a:srgbClr val="E2E8F2"/>
                 </a:solidFill>
                 <a:latin typeface="Inter" pitchFamily="34" charset="0"/>
                 <a:ea typeface="Inter" pitchFamily="34" charset="-122"/>
                 <a:cs typeface="Inter" pitchFamily="34" charset="-120"/>
               </a:rPr>
-              <a:t>Websites that reference your book. Public vouching you cannot write yourself.</a:t>
-            </a:r>
-            <a:endParaRPr lang="en-US" sz="1300" dirty="0"/>
+              <a:t>Respected websites that reference yours. Vouching you cannot write yourself.</a:t>
+            </a:r>
+            <a:endParaRPr lang="en-US" sz="1400" dirty="0"/>
           </a:p>
         </p:txBody>
       </p:sp>
@@ -8311,7 +8309,7 @@
               <a:buNone/>
             </a:pPr>
             <a:r>
-              <a:rPr lang="en-US" sz="1650" b="1" dirty="0">
+              <a:rPr lang="en-US" sz="1700" b="1" dirty="0">
                 <a:solidFill>
                   <a:srgbClr val="F8FAFC"/>
                 </a:solidFill>
@@ -8321,7 +8319,7 @@
               </a:rPr>
               <a:t>What readers say</a:t>
             </a:r>
-            <a:endParaRPr lang="en-US" sz="1650" dirty="0"/>
+            <a:endParaRPr lang="en-US" sz="1700" dirty="0"/>
           </a:p>
         </p:txBody>
       </p:sp>
@@ -8333,7 +8331,7 @@
         </p:nvSpPr>
         <p:spPr>
           <a:xfrm>
-            <a:off x="1627632" y="4928616"/>
+            <a:off x="1627632" y="4946904"/>
             <a:ext cx="5047488" cy="685800"/>
           </a:xfrm>
           <a:prstGeom prst="rect">
@@ -8353,9 +8351,9 @@
               <a:buNone/>
             </a:pPr>
             <a:r>
-              <a:rPr lang="en-US" sz="1300" dirty="0">
-                <a:solidFill>
-                  <a:srgbClr val="94A3B8"/>
+              <a:rPr lang="en-US" sz="1400" dirty="0">
+                <a:solidFill>
+                  <a:srgbClr val="E2E8F2"/>
                 </a:solidFill>
                 <a:latin typeface="Inter" pitchFamily="34" charset="0"/>
                 <a:ea typeface="Inter" pitchFamily="34" charset="-122"/>
@@ -8363,7 +8361,7 @@
               </a:rPr>
               <a:t>Reviews. The librarian reads every single one.</a:t>
             </a:r>
-            <a:endParaRPr lang="en-US" sz="1300" dirty="0"/>
+            <a:endParaRPr lang="en-US" sz="1400" dirty="0"/>
           </a:p>
         </p:txBody>
       </p:sp>
@@ -8494,7 +8492,7 @@
                 <a:ea typeface="Outfit" pitchFamily="34" charset="-122"/>
                 <a:cs typeface="Outfit" pitchFamily="34" charset="-120"/>
               </a:rPr>
-              <a:t>One rule: every flyer must match.</a:t>
+              <a:t>One rule: every reference must match.</a:t>
             </a:r>
             <a:endParaRPr lang="en-US" sz="1700" dirty="0"/>
           </a:p>
@@ -8528,9 +8526,9 @@
               <a:buNone/>
             </a:pPr>
             <a:r>
-              <a:rPr lang="en-US" sz="1300" dirty="0">
-                <a:solidFill>
-                  <a:srgbClr val="CBD5E1"/>
+              <a:rPr lang="en-US" sz="1400" dirty="0">
+                <a:solidFill>
+                  <a:srgbClr val="E2E8F2"/>
                 </a:solidFill>
                 <a:latin typeface="Inter" pitchFamily="34" charset="0"/>
                 <a:ea typeface="Inter" pitchFamily="34" charset="-122"/>
@@ -8538,7 +8536,7 @@
               </a:rPr>
               <a:t>A different name, phone, or address on each one, and the librarian trusts none of them.</a:t>
             </a:r>
-            <a:endParaRPr lang="en-US" sz="1300" dirty="0"/>
+            <a:endParaRPr lang="en-US" sz="1400" dirty="0"/>
           </a:p>
         </p:txBody>
       </p:sp>
@@ -8590,7 +8588,7 @@
         <p:spPr>
           <a:xfrm>
             <a:off x="822960" y="777240"/>
-            <a:ext cx="6400800" cy="292608"/>
+            <a:ext cx="6400800" cy="310896"/>
           </a:xfrm>
           <a:prstGeom prst="rect">
             <a:avLst/>
@@ -8606,7 +8604,7 @@
               <a:buNone/>
             </a:pPr>
             <a:r>
-              <a:rPr lang="en-US" sz="1100" b="1" spc="300" kern="0" dirty="0">
+              <a:rPr lang="en-US" sz="1200" b="1" spc="300" kern="0" dirty="0">
                 <a:solidFill>
                   <a:srgbClr val="38BDF8"/>
                 </a:solidFill>
@@ -8616,7 +8614,7 @@
               </a:rPr>
               <a:t>PUTTING IT TOGETHER</a:t>
             </a:r>
-            <a:endParaRPr lang="en-US" sz="1100" dirty="0"/>
+            <a:endParaRPr lang="en-US" sz="1200" dirty="0"/>
           </a:p>
         </p:txBody>
       </p:sp>
@@ -8800,7 +8798,7 @@
         </p:nvSpPr>
         <p:spPr>
           <a:xfrm>
-            <a:off x="1097280" y="3493008"/>
+            <a:off x="1097280" y="3511296"/>
             <a:ext cx="2788920" cy="640080"/>
           </a:xfrm>
           <a:prstGeom prst="rect">
@@ -8820,9 +8818,9 @@
               <a:buNone/>
             </a:pPr>
             <a:r>
-              <a:rPr lang="en-US" sz="1200" dirty="0">
-                <a:solidFill>
-                  <a:srgbClr val="94A3B8"/>
+              <a:rPr lang="en-US" sz="1300" dirty="0">
+                <a:solidFill>
+                  <a:srgbClr val="E2E8F2"/>
                 </a:solidFill>
                 <a:latin typeface="Inter" pitchFamily="34" charset="0"/>
                 <a:ea typeface="Inter" pitchFamily="34" charset="-122"/>
@@ -8830,7 +8828,7 @@
               </a:rPr>
               <a:t>Your site answers the question better than the next book on the shelf.</a:t>
             </a:r>
-            <a:endParaRPr lang="en-US" sz="1200" dirty="0"/>
+            <a:endParaRPr lang="en-US" sz="1300" dirty="0"/>
           </a:p>
         </p:txBody>
       </p:sp>
@@ -8958,7 +8956,7 @@
                 <a:ea typeface="Outfit" pitchFamily="34" charset="-122"/>
                 <a:cs typeface="Outfit" pitchFamily="34" charset="-120"/>
               </a:rPr>
-              <a:t>Flyers that agree</a:t>
+              <a:t>References that agree</a:t>
             </a:r>
             <a:endParaRPr lang="en-US" sz="1550" dirty="0"/>
           </a:p>
@@ -8972,7 +8970,7 @@
         </p:nvSpPr>
         <p:spPr>
           <a:xfrm>
-            <a:off x="4709160" y="3493008"/>
+            <a:off x="4709160" y="3511296"/>
             <a:ext cx="2788920" cy="640080"/>
           </a:xfrm>
           <a:prstGeom prst="rect">
@@ -8992,9 +8990,9 @@
               <a:buNone/>
             </a:pPr>
             <a:r>
-              <a:rPr lang="en-US" sz="1200" dirty="0">
-                <a:solidFill>
-                  <a:srgbClr val="94A3B8"/>
+              <a:rPr lang="en-US" sz="1300" dirty="0">
+                <a:solidFill>
+                  <a:srgbClr val="E2E8F2"/>
                 </a:solidFill>
                 <a:latin typeface="Inter" pitchFamily="34" charset="0"/>
                 <a:ea typeface="Inter" pitchFamily="34" charset="-122"/>
@@ -9002,7 +9000,7 @@
               </a:rPr>
               <a:t>Consistent evidence of you, everywhere the librarian looks.</a:t>
             </a:r>
-            <a:endParaRPr lang="en-US" sz="1200" dirty="0"/>
+            <a:endParaRPr lang="en-US" sz="1300" dirty="0"/>
           </a:p>
         </p:txBody>
       </p:sp>
@@ -9144,7 +9142,7 @@
         </p:nvSpPr>
         <p:spPr>
           <a:xfrm>
-            <a:off x="8321040" y="3493008"/>
+            <a:off x="8321040" y="3511296"/>
             <a:ext cx="2788920" cy="640080"/>
           </a:xfrm>
           <a:prstGeom prst="rect">
@@ -9164,9 +9162,9 @@
               <a:buNone/>
             </a:pPr>
             <a:r>
-              <a:rPr lang="en-US" sz="1200" dirty="0">
-                <a:solidFill>
-                  <a:srgbClr val="94A3B8"/>
+              <a:rPr lang="en-US" sz="1300" dirty="0">
+                <a:solidFill>
+                  <a:srgbClr val="E2E8F2"/>
                 </a:solidFill>
                 <a:latin typeface="Inter" pitchFamily="34" charset="0"/>
                 <a:ea typeface="Inter" pitchFamily="34" charset="-122"/>
@@ -9174,7 +9172,7 @@
               </a:rPr>
               <a:t>People choose your book, stay a while, and come back again.</a:t>
             </a:r>
-            <a:endParaRPr lang="en-US" sz="1200" dirty="0"/>
+            <a:endParaRPr lang="en-US" sz="1300" dirty="0"/>
           </a:p>
         </p:txBody>
       </p:sp>
@@ -9244,7 +9242,7 @@
               <a:buNone/>
             </a:pPr>
             <a:r>
-              <a:rPr lang="en-US" sz="1450" b="1" dirty="0">
+              <a:rPr lang="en-US" sz="1500" b="1" dirty="0">
                 <a:solidFill>
                   <a:srgbClr val="38BDF8"/>
                 </a:solidFill>
@@ -9252,7 +9250,7 @@
                 <a:ea typeface="Outfit" pitchFamily="34" charset="-122"/>
                 <a:cs typeface="Outfit" pitchFamily="34" charset="-120"/>
               </a:rPr>
-              <a:t>And the folding table out front?  </a:t>
+              <a:t>And the flyers handed out on the sidewalk?  </a:t>
             </a:r>
             <a:pPr indent="0" marL="0">
               <a:lnSpc>
@@ -9261,17 +9259,17 @@
               <a:buNone/>
             </a:pPr>
             <a:r>
-              <a:rPr lang="en-US" sz="1350" dirty="0">
-                <a:solidFill>
-                  <a:srgbClr val="CBD5E1"/>
+              <a:rPr lang="en-US" sz="1450" dirty="0">
+                <a:solidFill>
+                  <a:srgbClr val="E2E8F2"/>
                 </a:solidFill>
                 <a:latin typeface="Inter" pitchFamily="34" charset="0"/>
                 <a:ea typeface="Inter" pitchFamily="34" charset="-122"/>
                 <a:cs typeface="Inter" pitchFamily="34" charset="-120"/>
               </a:rPr>
-              <a:t>Paid ads. Clearly labeled, gone the moment you stop paying. The recommendation itself is not for sale, which is exactly why it is worth more.</a:t>
-            </a:r>
-            <a:endParaRPr lang="en-US" sz="1450" dirty="0"/>
+              <a:t>Paid ads. Everyone can print one, and they vanish the moment you stop paying. The recommendation itself is not for sale, which is exactly why it is worth more.</a:t>
+            </a:r>
+            <a:endParaRPr lang="en-US" sz="1500" dirty="0"/>
           </a:p>
         </p:txBody>
       </p:sp>
@@ -9323,7 +9321,7 @@
         <p:spPr>
           <a:xfrm>
             <a:off x="822960" y="777240"/>
-            <a:ext cx="6400800" cy="292608"/>
+            <a:ext cx="6400800" cy="310896"/>
           </a:xfrm>
           <a:prstGeom prst="rect">
             <a:avLst/>
@@ -9339,7 +9337,7 @@
               <a:buNone/>
             </a:pPr>
             <a:r>
-              <a:rPr lang="en-US" sz="1100" b="1" spc="300" kern="0" dirty="0">
+              <a:rPr lang="en-US" sz="1200" b="1" spc="300" kern="0" dirty="0">
                 <a:solidFill>
                   <a:srgbClr val="38BDF8"/>
                 </a:solidFill>
@@ -9349,7 +9347,7 @@
               </a:rPr>
               <a:t>CLEARING THE FOG</a:t>
             </a:r>
-            <a:endParaRPr lang="en-US" sz="1100" dirty="0"/>
+            <a:endParaRPr lang="en-US" sz="1200" dirty="0"/>
           </a:p>
         </p:txBody>
       </p:sp>
@@ -9533,7 +9531,7 @@
         </p:nvSpPr>
         <p:spPr>
           <a:xfrm>
-            <a:off x="1828800" y="2843784"/>
+            <a:off x="1828800" y="2862072"/>
             <a:ext cx="3886200" cy="777240"/>
           </a:xfrm>
           <a:prstGeom prst="rect">
@@ -9553,9 +9551,9 @@
               <a:buNone/>
             </a:pPr>
             <a:r>
-              <a:rPr lang="en-US" sz="1250" dirty="0">
-                <a:solidFill>
-                  <a:srgbClr val="94A3B8"/>
+              <a:rPr lang="en-US" sz="1350" dirty="0">
+                <a:solidFill>
+                  <a:srgbClr val="E2E8F2"/>
                 </a:solidFill>
                 <a:latin typeface="Inter" pitchFamily="34" charset="0"/>
                 <a:ea typeface="Inter" pitchFamily="34" charset="-122"/>
@@ -9563,7 +9561,7 @@
               </a:rPr>
               <a:t>The library reshelves every day. SEO is a habit, not a project.</a:t>
             </a:r>
-            <a:endParaRPr lang="en-US" sz="1250" dirty="0"/>
+            <a:endParaRPr lang="en-US" sz="1350" dirty="0"/>
           </a:p>
         </p:txBody>
       </p:sp>
@@ -9705,7 +9703,7 @@
         </p:nvSpPr>
         <p:spPr>
           <a:xfrm>
-            <a:off x="7178040" y="2843784"/>
+            <a:off x="7178040" y="2862072"/>
             <a:ext cx="3886200" cy="777240"/>
           </a:xfrm>
           <a:prstGeom prst="rect">
@@ -9725,9 +9723,9 @@
               <a:buNone/>
             </a:pPr>
             <a:r>
-              <a:rPr lang="en-US" sz="1250" dirty="0">
-                <a:solidFill>
-                  <a:srgbClr val="94A3B8"/>
+              <a:rPr lang="en-US" sz="1350" dirty="0">
+                <a:solidFill>
+                  <a:srgbClr val="E2E8F2"/>
                 </a:solidFill>
                 <a:latin typeface="Inter" pitchFamily="34" charset="0"/>
                 <a:ea typeface="Inter" pitchFamily="34" charset="-122"/>
@@ -9735,7 +9733,7 @@
               </a:rPr>
               <a:t>Saying plumber forty times does not impress a librarian who reads.</a:t>
             </a:r>
-            <a:endParaRPr lang="en-US" sz="1250" dirty="0"/>
+            <a:endParaRPr lang="en-US" sz="1350" dirty="0"/>
           </a:p>
         </p:txBody>
       </p:sp>
@@ -9877,7 +9875,7 @@
         </p:nvSpPr>
         <p:spPr>
           <a:xfrm>
-            <a:off x="1828800" y="4672584"/>
+            <a:off x="1828800" y="4690872"/>
             <a:ext cx="3886200" cy="777240"/>
           </a:xfrm>
           <a:prstGeom prst="rect">
@@ -9897,17 +9895,17 @@
               <a:buNone/>
             </a:pPr>
             <a:r>
-              <a:rPr lang="en-US" sz="1250" dirty="0">
-                <a:solidFill>
-                  <a:srgbClr val="94A3B8"/>
+              <a:rPr lang="en-US" sz="1350" dirty="0">
+                <a:solidFill>
+                  <a:srgbClr val="E2E8F2"/>
                 </a:solidFill>
                 <a:latin typeface="Inter" pitchFamily="34" charset="0"/>
                 <a:ea typeface="Inter" pitchFamily="34" charset="-122"/>
                 <a:cs typeface="Inter" pitchFamily="34" charset="-120"/>
               </a:rPr>
-              <a:t>Money buys the folding table. It never buys the shelf.</a:t>
-            </a:r>
-            <a:endParaRPr lang="en-US" sz="1250" dirty="0"/>
+              <a:t>Money buys the sidewalk flyers. It never buys the shelf.</a:t>
+            </a:r>
+            <a:endParaRPr lang="en-US" sz="1350" dirty="0"/>
           </a:p>
         </p:txBody>
       </p:sp>
@@ -10049,7 +10047,7 @@
         </p:nvSpPr>
         <p:spPr>
           <a:xfrm>
-            <a:off x="7178040" y="4672584"/>
+            <a:off x="7178040" y="4690872"/>
             <a:ext cx="3886200" cy="777240"/>
           </a:xfrm>
           <a:prstGeom prst="rect">
@@ -10069,9 +10067,9 @@
               <a:buNone/>
             </a:pPr>
             <a:r>
-              <a:rPr lang="en-US" sz="1250" dirty="0">
-                <a:solidFill>
-                  <a:srgbClr val="94A3B8"/>
+              <a:rPr lang="en-US" sz="1350" dirty="0">
+                <a:solidFill>
+                  <a:srgbClr val="E2E8F2"/>
                 </a:solidFill>
                 <a:latin typeface="Inter" pitchFamily="34" charset="0"/>
                 <a:ea typeface="Inter" pitchFamily="34" charset="-122"/>
@@ -10079,7 +10077,7 @@
               </a:rPr>
               <a:t>It is a trust system. Explainable, measurable, and it compounds.</a:t>
             </a:r>
-            <a:endParaRPr lang="en-US" sz="1250" dirty="0"/>
+            <a:endParaRPr lang="en-US" sz="1350" dirty="0"/>
           </a:p>
         </p:txBody>
       </p:sp>
@@ -10131,7 +10129,7 @@
         <p:spPr>
           <a:xfrm>
             <a:off x="822960" y="777240"/>
-            <a:ext cx="6400800" cy="292608"/>
+            <a:ext cx="6400800" cy="310896"/>
           </a:xfrm>
           <a:prstGeom prst="rect">
             <a:avLst/>
@@ -10147,7 +10145,7 @@
               <a:buNone/>
             </a:pPr>
             <a:r>
-              <a:rPr lang="en-US" sz="1100" b="1" spc="300" kern="0" dirty="0">
+              <a:rPr lang="en-US" sz="1200" b="1" spc="300" kern="0" dirty="0">
                 <a:solidFill>
                   <a:srgbClr val="38BDF8"/>
                 </a:solidFill>
@@ -10157,7 +10155,7 @@
               </a:rPr>
               <a:t>THE LOCAL TWIST</a:t>
             </a:r>
-            <a:endParaRPr lang="en-US" sz="1100" dirty="0"/>
+            <a:endParaRPr lang="en-US" sz="1200" dirty="0"/>
           </a:p>
         </p:txBody>
       </p:sp>
@@ -10231,9 +10229,9 @@
               <a:buNone/>
             </a:pPr>
             <a:r>
-              <a:rPr lang="en-US" sz="1500" dirty="0">
-                <a:solidFill>
-                  <a:srgbClr val="CBD5E1"/>
+              <a:rPr lang="en-US" sz="1600" dirty="0">
+                <a:solidFill>
+                  <a:srgbClr val="E2E8F2"/>
                 </a:solidFill>
                 <a:latin typeface="Inter" pitchFamily="34" charset="0"/>
                 <a:ea typeface="Inter" pitchFamily="34" charset="-122"/>
@@ -10241,7 +10239,7 @@
               </a:rPr>
               <a:t>For local searches the librarian keeps a short shelf right at the entrance: three names, a map, hours, reviews. Most customers never walk past it.</a:t>
             </a:r>
-            <a:endParaRPr lang="en-US" sz="1500" dirty="0"/>
+            <a:endParaRPr lang="en-US" sz="1600" dirty="0"/>
           </a:p>
         </p:txBody>
       </p:sp>

</xml_diff>